<commit_message>
Update repository references from ibm-hackathon to standup-sync
The project repository has been renamed from `DonCastillo/ibm-hackathon` to `DonCastillo/standup-sync`. Update all GitHub URLs, clone instructions, and repository references across documentation, frontend code, pitch deck materials, and task tracking to reflect the new repository name.
</commit_message>
<xml_diff>
--- a/deliverables/Standup Sync — Pitch Deck (1).pptx
+++ b/deliverables/Standup Sync — Pitch Deck (1).pptx
@@ -2191,7 +2191,25 @@
                 <a:ea typeface="Arial" pitchFamily="34" charset="-122"/>
                 <a:cs typeface="Arial" pitchFamily="34" charset="-120"/>
               </a:rPr>
-              <a:t>Code, tests and Bob session exports: github.com/DonCastillo/ibm-hackathon</a:t>
+              <a:t>Code, tests and Bob session exports: </a:t>
+            </a:r>
+            <a:r>
+              <a:rPr lang="en-US" sz="1600" u="sng" dirty="0">
+                <a:solidFill>
+                  <a:srgbClr val="1B1B17"/>
+                </a:solidFill>
+                <a:latin typeface="Arial" pitchFamily="34" charset="0"/>
+                <a:ea typeface="Arial" pitchFamily="34" charset="-122"/>
+                <a:cs typeface="Arial" pitchFamily="34" charset="-120"/>
+                <a:hlinkClick r:id="rId1" invalidUrl="" action="" tgtFrame="" tooltip="" history="1" highlightClick="0" endSnd="0">
+                  <a:extLst>
+                    <a:ext uri="{A12FA001-AC4F-418D-AE19-62706E023703}">
+                      <ahyp:hlinkClr xmlns:ahyp="http://schemas.microsoft.com/office/drawing/2018/hyperlinkcolor" val="tx"/>
+                    </a:ext>
+                  </a:extLst>
+                </a:hlinkClick>
+              </a:rPr>
+              <a:t>https://github.com/DonCastillo/standup-sync</a:t>
             </a:r>
             <a:endParaRPr lang="en-US" sz="1600" dirty="0"/>
           </a:p>

</xml_diff>